<commit_message>
Move website files to root for GitHub Pages
</commit_message>
<xml_diff>
--- a/presentation.pptx
+++ b/presentation.pptx
@@ -5,20 +5,20 @@
     <p:sldMasterId id="2147483648" r:id="rId1"/>
   </p:sldMasterIdLst>
   <p:notesMasterIdLst>
-    <p:notesMasterId r:id="rId4"/>
+    <p:notesMasterId r:id="rId5"/>
   </p:notesMasterIdLst>
   <p:handoutMasterIdLst>
-    <p:handoutMasterId r:id="rId7"/>
+    <p:handoutMasterId r:id="rId6"/>
   </p:handoutMasterIdLst>
   <p:sldIdLst>
-    <p:sldId id="273" r:id="rId3"/>
-    <p:sldId id="270" r:id="rId5"/>
-    <p:sldId id="274" r:id="rId6"/>
+    <p:sldId id="273" r:id="rId2"/>
+    <p:sldId id="270" r:id="rId3"/>
+    <p:sldId id="274" r:id="rId4"/>
   </p:sldIdLst>
   <p:sldSz cx="12192000" cy="6858000"/>
   <p:notesSz cx="6858000" cy="9144000"/>
   <p:custDataLst>
-    <p:tags r:id="rId12"/>
+    <p:tags r:id="rId7"/>
   </p:custDataLst>
   <p:defaultTextStyle>
     <a:defPPr rtl="0">
@@ -130,6 +130,9 @@
         </p15:guide>
       </p15:sldGuideLst>
     </p:ext>
+    <p:ext uri="{2D200454-40CA-4A62-9FC3-DE9A4176ACB9}">
+      <p15:notesGuideLst xmlns:p15="http://schemas.microsoft.com/office/powerpoint/2012/main"/>
+    </p:ext>
   </p:extLst>
 </p:presentation>
 </file>
@@ -228,6 +231,7 @@
                 <a:latin typeface="Microsoft YaHei UI" panose="020B0503020204020204" pitchFamily="34" charset="-122"/>
                 <a:ea typeface="Microsoft YaHei UI" panose="020B0503020204020204" pitchFamily="34" charset="-122"/>
               </a:rPr>
+              <a:t>2026年1月18日</a:t>
             </a:fld>
             <a:endParaRPr lang="zh-CN" altLang="en-US" dirty="0">
               <a:latin typeface="Microsoft YaHei UI" panose="020B0503020204020204" pitchFamily="34" charset="-122"/>
@@ -302,6 +306,7 @@
                 <a:latin typeface="Microsoft YaHei UI" panose="020B0503020204020204" pitchFamily="34" charset="-122"/>
                 <a:ea typeface="Microsoft YaHei UI" panose="020B0503020204020204" pitchFamily="34" charset="-122"/>
               </a:rPr>
+              <a:t>‹#›</a:t>
             </a:fld>
             <a:endParaRPr lang="zh-CN" altLang="en-US" dirty="0">
               <a:latin typeface="Microsoft YaHei UI" panose="020B0503020204020204" pitchFamily="34" charset="-122"/>
@@ -311,6 +316,11 @@
         </p:txBody>
       </p:sp>
     </p:spTree>
+    <p:extLst>
+      <p:ext uri="{BB962C8B-B14F-4D97-AF65-F5344CB8AC3E}">
+        <p14:creationId xmlns:p14="http://schemas.microsoft.com/office/powerpoint/2010/main" val="1"/>
+      </p:ext>
+    </p:extLst>
   </p:cSld>
   <p:clrMap bg1="lt1" tx1="dk1" bg2="lt2" tx2="dk2" accent1="accent1" accent2="accent2" accent3="accent3" accent4="accent4" accent5="accent5" accent6="accent6" hlink="hlink" folHlink="folHlink"/>
   <p:hf hdr="0" ftr="0" dt="0"/>
@@ -405,6 +415,7 @@
           <a:p>
             <a:fld id="{70747F27-0AFF-49DE-ABD2-AA502995B8AE}" type="datetime2">
               <a:rPr lang="zh-CN" altLang="en-US" smtClean="0"/>
+              <a:t>2026年1月18日</a:t>
             </a:fld>
             <a:endParaRPr lang="en-US" dirty="0"/>
           </a:p>
@@ -472,7 +483,6 @@
               <a:rPr lang="en-US" dirty="0"/>
               <a:t>单击此处编辑母版文本样式</a:t>
             </a:r>
-            <a:endParaRPr lang="en-US" dirty="0"/>
           </a:p>
           <a:p>
             <a:pPr lvl="1" rtl="0"/>
@@ -480,7 +490,6 @@
               <a:rPr lang="en-US" dirty="0"/>
               <a:t>第二级</a:t>
             </a:r>
-            <a:endParaRPr lang="en-US" dirty="0"/>
           </a:p>
           <a:p>
             <a:pPr lvl="2" rtl="0"/>
@@ -488,7 +497,6 @@
               <a:rPr lang="en-US" dirty="0"/>
               <a:t>第三级</a:t>
             </a:r>
-            <a:endParaRPr lang="en-US" dirty="0"/>
           </a:p>
           <a:p>
             <a:pPr lvl="3" rtl="0"/>
@@ -496,7 +504,6 @@
               <a:rPr lang="en-US" dirty="0"/>
               <a:t>第四级</a:t>
             </a:r>
-            <a:endParaRPr lang="en-US" dirty="0"/>
           </a:p>
           <a:p>
             <a:pPr lvl="4" rtl="0"/>
@@ -504,7 +511,6 @@
               <a:rPr lang="en-US" dirty="0"/>
               <a:t>第五级</a:t>
             </a:r>
-            <a:endParaRPr lang="en-US" dirty="0"/>
           </a:p>
         </p:txBody>
       </p:sp>
@@ -574,6 +580,7 @@
           <a:p>
             <a:fld id="{DF61EA0F-A667-4B49-8422-0062BC55E249}" type="slidenum">
               <a:rPr lang="en-US" smtClean="0"/>
+              <a:t>‹#›</a:t>
             </a:fld>
             <a:endParaRPr lang="en-US" dirty="0"/>
           </a:p>
@@ -750,6 +757,7 @@
             <a:pPr rtl="0"/>
             <a:fld id="{DF61EA0F-A667-4B49-8422-0062BC55E249}" type="slidenum">
               <a:rPr lang="en-US" altLang="zh-CN" smtClean="0"/>
+              <a:t>1</a:t>
             </a:fld>
             <a:endParaRPr lang="zh-CN" altLang="en-US" dirty="0"/>
           </a:p>
@@ -830,6 +838,7 @@
             <a:pPr rtl="0"/>
             <a:fld id="{DF61EA0F-A667-4B49-8422-0062BC55E249}" type="slidenum">
               <a:rPr lang="en-US" smtClean="0"/>
+              <a:t>2</a:t>
             </a:fld>
             <a:endParaRPr lang="en-US"/>
           </a:p>
@@ -907,7 +916,6 @@
               <a:rPr lang="en-US" dirty="0"/>
               <a:t>。</a:t>
             </a:r>
-            <a:endParaRPr lang="en-US" dirty="0"/>
           </a:p>
         </p:txBody>
       </p:sp>
@@ -929,6 +937,7 @@
             <a:pPr rtl="0"/>
             <a:fld id="{DF61EA0F-A667-4B49-8422-0062BC55E249}" type="slidenum">
               <a:rPr lang="en-US" smtClean="0"/>
+              <a:t>3</a:t>
             </a:fld>
             <a:endParaRPr lang="en-US"/>
           </a:p>
@@ -1285,6 +1294,7 @@
           <a:p>
             <a:fld id="{94B3CDE5-BC73-4849-8D92-CB00948283D7}" type="datetime2">
               <a:rPr lang="zh-CN" altLang="en-US" smtClean="0"/>
+              <a:t>2026年1月18日</a:t>
             </a:fld>
             <a:endParaRPr lang="en-US"/>
           </a:p>
@@ -1352,6 +1362,7 @@
           <a:p>
             <a:fld id="{9860EDB8-5305-433F-BE41-D7A86D811DB3}" type="slidenum">
               <a:rPr lang="en-US" smtClean="0"/>
+              <a:t>‹#›</a:t>
             </a:fld>
             <a:endParaRPr lang="en-US"/>
           </a:p>
@@ -1540,7 +1551,6 @@
               <a:rPr lang="zh-CN" altLang="en-US" noProof="0" dirty="0"/>
               <a:t>单击此处编辑母版标题样式</a:t>
             </a:r>
-            <a:endParaRPr lang="zh-CN" altLang="en-US" noProof="0" dirty="0"/>
           </a:p>
         </p:txBody>
       </p:sp>
@@ -1574,7 +1584,6 @@
               <a:rPr lang="zh-CN" altLang="en-US" noProof="0" dirty="0"/>
               <a:t>编辑母版文本样式</a:t>
             </a:r>
-            <a:endParaRPr lang="zh-CN" altLang="en-US" noProof="0" dirty="0"/>
           </a:p>
           <a:p>
             <a:pPr lvl="1" rtl="0"/>
@@ -1582,7 +1591,6 @@
               <a:rPr lang="zh-CN" altLang="en-US" noProof="0" dirty="0"/>
               <a:t>第二级</a:t>
             </a:r>
-            <a:endParaRPr lang="zh-CN" altLang="en-US" noProof="0" dirty="0"/>
           </a:p>
           <a:p>
             <a:pPr lvl="2" rtl="0"/>
@@ -1590,7 +1598,6 @@
               <a:rPr lang="zh-CN" altLang="en-US" noProof="0" dirty="0"/>
               <a:t>第三级</a:t>
             </a:r>
-            <a:endParaRPr lang="zh-CN" altLang="en-US" noProof="0" dirty="0"/>
           </a:p>
           <a:p>
             <a:pPr lvl="3" rtl="0"/>
@@ -1598,7 +1605,6 @@
               <a:rPr lang="zh-CN" altLang="en-US" noProof="0" dirty="0"/>
               <a:t>第四级</a:t>
             </a:r>
-            <a:endParaRPr lang="zh-CN" altLang="en-US" noProof="0" dirty="0"/>
           </a:p>
           <a:p>
             <a:pPr lvl="4" rtl="0"/>
@@ -1606,7 +1612,6 @@
               <a:rPr lang="zh-CN" altLang="en-US" noProof="0" dirty="0"/>
               <a:t>第五级</a:t>
             </a:r>
-            <a:endParaRPr lang="zh-CN" altLang="en-US" noProof="0" dirty="0"/>
           </a:p>
         </p:txBody>
       </p:sp>
@@ -1648,6 +1653,7 @@
           <a:p>
             <a:fld id="{131E3292-D461-4042-A5EB-629C7A8279A7}" type="datetime2">
               <a:rPr lang="zh-CN" altLang="en-US" smtClean="0"/>
+              <a:t>2026年1月18日</a:t>
             </a:fld>
             <a:endParaRPr lang="zh-CN" altLang="en-US" dirty="0"/>
           </a:p>
@@ -1731,6 +1737,7 @@
           <a:p>
             <a:fld id="{9860EDB8-5305-433F-BE41-D7A86D811DB3}" type="slidenum">
               <a:rPr lang="en-US" altLang="zh-CN" smtClean="0"/>
+              <a:t>‹#›</a:t>
             </a:fld>
             <a:endParaRPr lang="zh-CN" altLang="en-US" dirty="0"/>
           </a:p>
@@ -2099,16 +2106,7 @@
                 </a:solidFill>
                 <a:cs typeface="Arial" panose="020B0604020202020204" pitchFamily="34" charset="0"/>
               </a:rPr>
-              <a:t>级大</a:t>
-            </a:r>
-            <a:r>
-              <a:rPr lang="zh-CN" altLang="en-US" sz="4600">
-                <a:solidFill>
-                  <a:schemeClr val="bg1"/>
-                </a:solidFill>
-                <a:cs typeface="Arial" panose="020B0604020202020204" pitchFamily="34" charset="0"/>
-              </a:rPr>
-              <a:t>一上作业</a:t>
+              <a:t>级大一上作业</a:t>
             </a:r>
             <a:r>
               <a:rPr lang="zh-CN" altLang="en-US" sz="4600" dirty="0">
@@ -2196,7 +2194,7 @@
                 <a:cs typeface="Arial" panose="020B0604020202020204" pitchFamily="34" charset="0"/>
                 <a:sym typeface="Wingdings" panose="05000000000000000000" pitchFamily="2" charset="2"/>
               </a:rPr>
-              <a:t>：姓名</a:t>
+              <a:t>：雷宇</a:t>
             </a:r>
             <a:r>
               <a:rPr lang="en-US" altLang="zh-CN" sz="2400" dirty="0">
@@ -2216,7 +2214,7 @@
                 <a:cs typeface="Arial" panose="020B0604020202020204" pitchFamily="34" charset="0"/>
                 <a:sym typeface="Wingdings" panose="05000000000000000000" pitchFamily="2" charset="2"/>
               </a:rPr>
-              <a:t>班级</a:t>
+              <a:t>求实</a:t>
             </a:r>
             <a:r>
               <a:rPr lang="en-US" altLang="zh-CN" sz="2400" dirty="0">
@@ -2226,7 +2224,27 @@
                 <a:cs typeface="Arial" panose="020B0604020202020204" pitchFamily="34" charset="0"/>
                 <a:sym typeface="Wingdings" panose="05000000000000000000" pitchFamily="2" charset="2"/>
               </a:rPr>
-              <a:t> QQ</a:t>
+              <a:t>2501 QQ</a:t>
+            </a:r>
+            <a:r>
+              <a:rPr lang="zh-CN" altLang="en-US" sz="2400" dirty="0">
+                <a:solidFill>
+                  <a:schemeClr val="bg1"/>
+                </a:solidFill>
+                <a:cs typeface="Arial" panose="020B0604020202020204" pitchFamily="34" charset="0"/>
+                <a:sym typeface="Wingdings" panose="05000000000000000000" pitchFamily="2" charset="2"/>
+              </a:rPr>
+              <a:t>：</a:t>
+            </a:r>
+            <a:r>
+              <a:rPr lang="en-US" altLang="zh-CN" sz="2400">
+                <a:solidFill>
+                  <a:schemeClr val="bg1"/>
+                </a:solidFill>
+                <a:cs typeface="Arial" panose="020B0604020202020204" pitchFamily="34" charset="0"/>
+                <a:sym typeface="Wingdings" panose="05000000000000000000" pitchFamily="2" charset="2"/>
+              </a:rPr>
+              <a:t>3012291549</a:t>
             </a:r>
             <a:endParaRPr lang="en-US" altLang="zh-CN" sz="2400" dirty="0">
               <a:solidFill>
@@ -2257,12 +2275,6 @@
               </a:rPr>
               <a:t>2026.XX.XX</a:t>
             </a:r>
-            <a:endParaRPr lang="en-US" sz="2400" dirty="0">
-              <a:solidFill>
-                <a:schemeClr val="bg1"/>
-              </a:solidFill>
-              <a:cs typeface="Arial" panose="020B0604020202020204" pitchFamily="34" charset="0"/>
-            </a:endParaRPr>
           </a:p>
         </p:txBody>
       </p:sp>
@@ -2315,9 +2327,6 @@
               </a:rPr>
               <a:t>子标题</a:t>
             </a:r>
-            <a:endParaRPr lang="zh-CN" altLang="en-US" sz="4800" dirty="0">
-              <a:cs typeface="Arial" panose="020B0604020202020204" pitchFamily="34" charset="0"/>
-            </a:endParaRPr>
           </a:p>
         </p:txBody>
       </p:sp>
@@ -2375,11 +2384,6 @@
               </a:rPr>
               <a:t>结束语</a:t>
             </a:r>
-            <a:endParaRPr lang="zh-CN" altLang="en-US" dirty="0">
-              <a:solidFill>
-                <a:srgbClr val="FF0000"/>
-              </a:solidFill>
-            </a:endParaRPr>
           </a:p>
         </p:txBody>
       </p:sp>
@@ -2388,13 +2392,13 @@
   <p:clrMapOvr>
     <a:masterClrMapping/>
   </p:clrMapOvr>
-  <mc:AlternateContent xmlns:mc="http://schemas.openxmlformats.org/markup-compatibility/2006">
-    <mc:Choice xmlns:p15="http://schemas.microsoft.com/office/powerpoint/2012/main" Requires="p15">
-      <p:transition xmlns:p14="http://schemas.microsoft.com/office/powerpoint/2010/main" spd="slow" Requires="p14" p14:dur="2000">
+  <mc:AlternateContent xmlns:mc="http://schemas.openxmlformats.org/markup-compatibility/2006" xmlns:p15="http://schemas.microsoft.com/office/powerpoint/2012/main">
+    <mc:Choice Requires="p15">
+      <p:transition xmlns:p14="http://schemas.microsoft.com/office/powerpoint/2010/main" spd="slow" p14:dur="2000">
         <p15:prstTrans prst="drape"/>
       </p:transition>
     </mc:Choice>
-    <mc:Fallback>
+    <mc:Fallback xmlns="">
       <p:transition spd="slow">
         <p:fade/>
       </p:transition>
@@ -2404,7 +2408,7 @@
 </file>
 
 <file path=ppt/tags/tag1.xml><?xml version="1.0" encoding="utf-8"?>
-<p:tagLst xmlns:p="http://schemas.openxmlformats.org/presentationml/2006/main">
+<p:tagLst xmlns:a="http://schemas.openxmlformats.org/drawingml/2006/main" xmlns:r="http://schemas.openxmlformats.org/officeDocument/2006/relationships" xmlns:p="http://schemas.openxmlformats.org/presentationml/2006/main">
   <p:tag name="KSO_WPP_MARK_KEY" val="1c29d4c5-cc17-4b6f-87aa-cc5e40ecfbd0"/>
   <p:tag name="COMMONDATA" val="eyJoZGlkIjoiYjdlZjIwZmNkNzI3MzEwMzZmOTQyZTUzYzc4MjYwZjAifQ=="/>
 </p:tagLst>
@@ -2661,6 +2665,8 @@
       </a:bgFillStyleLst>
     </a:fmtScheme>
   </a:themeElements>
+  <a:objectDefaults/>
+  <a:extraClrSchemeLst/>
   <a:extLst>
     <a:ext uri="{05A4C25C-085E-4340-85A3-A5531E510DB2}">
       <thm15:themeFamily xmlns:thm15="http://schemas.microsoft.com/office/thememl/2012/main" name="Office Theme" id="{62F939B6-93AF-4DB8-9C6B-D6C7DFDC589F}" vid="{4A3C46E8-61CC-4603-A589-7422A47A8E4A}"/>
@@ -2920,6 +2926,8 @@
       </a:bgFillStyleLst>
     </a:fmtScheme>
   </a:themeElements>
+  <a:objectDefaults/>
+  <a:extraClrSchemeLst/>
   <a:extLst>
     <a:ext uri="{05A4C25C-085E-4340-85A3-A5531E510DB2}">
       <thm15:themeFamily xmlns:thm15="http://schemas.microsoft.com/office/thememl/2012/main" name="Office Theme" id="{62F939B6-93AF-4DB8-9C6B-D6C7DFDC589F}" vid="{4A3C46E8-61CC-4603-A589-7422A47A8E4A}"/>
@@ -3179,6 +3187,8 @@
       </a:bgFillStyleLst>
     </a:fmtScheme>
   </a:themeElements>
+  <a:objectDefaults/>
+  <a:extraClrSchemeLst/>
   <a:extLst>
     <a:ext uri="{05A4C25C-085E-4340-85A3-A5531E510DB2}">
       <thm15:themeFamily xmlns:thm15="http://schemas.microsoft.com/office/thememl/2012/main" name="Office Theme" id="{62F939B6-93AF-4DB8-9C6B-D6C7DFDC589F}" vid="{4A3C46E8-61CC-4603-A589-7422A47A8E4A}"/>

</xml_diff>